<commit_message>
docs: update report and slides with verified Docker and green CI results
</commit_message>
<xml_diff>
--- a/slides/bailar.pptx
+++ b/slides/bailar.pptx
@@ -2,16 +2,16 @@
 <file path=ppt/presentation.xml><?xml version="1.0" encoding="utf-8"?>
 <p:presentation xmlns:p="http://schemas.openxmlformats.org/presentationml/2006/main">
   <p:sldMasterIdLst>
-    <p:sldMasterId xmlns:r="http://schemas.openxmlformats.org/officeDocument/2006/relationships" id="2147483648" r:id="R4fc18bbd86924605"/>
+    <p:sldMasterId xmlns:r="http://schemas.openxmlformats.org/officeDocument/2006/relationships" id="2147483648" r:id="Rb8034bd224c04d9e"/>
   </p:sldMasterIdLst>
   <p:notesMasterIdLst>
-    <p:notesMasterId xmlns:r="http://schemas.openxmlformats.org/officeDocument/2006/relationships" r:id="Rb9f60d1768f14104"/>
+    <p:notesMasterId xmlns:r="http://schemas.openxmlformats.org/officeDocument/2006/relationships" r:id="R9c742aaa555c4080"/>
   </p:notesMasterIdLst>
   <p:sldIdLst>
-    <p:sldId xmlns:r="http://schemas.openxmlformats.org/officeDocument/2006/relationships" id="256" r:id="R5aa81fad45684cb3"/>
-    <p:sldId xmlns:r="http://schemas.openxmlformats.org/officeDocument/2006/relationships" id="257" r:id="R128bb848bf094e14"/>
-    <p:sldId xmlns:r="http://schemas.openxmlformats.org/officeDocument/2006/relationships" id="258" r:id="Rcf3a669412ce4810"/>
-    <p:sldId xmlns:r="http://schemas.openxmlformats.org/officeDocument/2006/relationships" id="259" r:id="Re2642bd672514a4c"/>
+    <p:sldId xmlns:r="http://schemas.openxmlformats.org/officeDocument/2006/relationships" id="256" r:id="R9d7210d4b18c4a65"/>
+    <p:sldId xmlns:r="http://schemas.openxmlformats.org/officeDocument/2006/relationships" id="257" r:id="R8132971abca14444"/>
+    <p:sldId xmlns:r="http://schemas.openxmlformats.org/officeDocument/2006/relationships" id="258" r:id="Rff73d0d3e4734119"/>
+    <p:sldId xmlns:r="http://schemas.openxmlformats.org/officeDocument/2006/relationships" id="259" r:id="R666d131a1e5f4eb8"/>
   </p:sldIdLst>
   <p:sldSz cx="12192000" cy="6858000"/>
   <p:notesSz cx="6858000" cy="9144000"/>
@@ -585,7 +585,7 @@
           <a:lstStyle xmlns:a="http://schemas.openxmlformats.org/drawingml/2006/main"/>
           <a:p xmlns:a="http://schemas.openxmlformats.org/drawingml/2006/main">
             <a:r>
-              <a:t>Owner: Bailar. Sources: Dockerfile, .dockerignore, .github/workflows/ci.yml and report/report.md. Both image stages use python:3.12.6-slim. Appuser owns /app for SQLite and output files. CI smoke commands run with --network none. Docker was unavailable locally, so build/run is pending. Global lint and mypy failures in other owners/frozen files remain. Branch protection must require CI checks.</a:t>
+              <a:t>Owner: Bailar. Sources: Dockerfile, .dockerignore, .github/workflows/ci.yml and report/report.md. Both stages use python:3.12.6-slim. Appuser owns /app. All Docker steps passed in https://github.com/nuralnetworks/async-research-assistant/actions/runs/35284135541/job/105412575476 at head f090268. CI used --network none. Nural supplied the dependency fix in e03e8cf. Local Windows Docker and live provider runs are not claimed.</a:t>
             </a:r>
           </a:p>
         </p:txBody>
@@ -655,7 +655,7 @@
           <a:lstStyle xmlns:a="http://schemas.openxmlformats.org/drawingml/2006/main"/>
           <a:p xmlns:a="http://schemas.openxmlformats.org/drawingml/2006/main">
             <a:r>
-              <a:t>Sources: report/report.md and supplied ownership rules. Suggested answers: the CLI null cache prevents persistent storage construction under --no-cache; fake Researcher isolates the CLI contract; the team release still needs Docker verification, other owners lint/type fixes and report/slide submissions. AI disclosure: Codex assisted Bailar-owned code, documentation and these slides.</a:t>
+              <a:t>Sources: report/report.md and supplied ownership rules. Suggested answers: the CLI null cache prevents persistent storage construction under --no-cache; fake Researcher isolates the CLI contract; team release still needs authored report sections, contribution statements, slides and PR approval. Final tag and Moodle upload are deferred. AI disclosure: Codex assisted Bailar-owned code, documentation and these slides.</a:t>
             </a:r>
           </a:p>
         </p:txBody>
@@ -723,7 +723,7 @@
   </p:cSld>
   <p:clrMap bg1="lt1" tx1="dk1" bg2="lt2" tx2="dk2" accent1="accent1" accent2="accent2" accent3="accent3" accent4="accent4" accent5="accent5" accent6="accent6" hlink="hlink" folHlink="folHlink"/>
   <p:sldLayoutIdLst>
-    <p:sldLayoutId xmlns:r="http://schemas.openxmlformats.org/officeDocument/2006/relationships" id="2147483649" r:id="R066b95e36ccf4fb9"/>
+    <p:sldLayoutId xmlns:r="http://schemas.openxmlformats.org/officeDocument/2006/relationships" id="2147483649" r:id="R3d11130673a44890"/>
   </p:sldLayoutIdLst>
   <p:txStyles>
     <p:titleStyle>
@@ -1274,7 +1274,7 @@
           <p:cNvPr id="5" name="">
             <a:extLst xmlns:a="http://schemas.openxmlformats.org/drawingml/2006/main">
               <a:ext uri="{FF2B5EF4-FFF2-40B4-BE49-F238E27FC236}">
-                <a16:creationId xmlns:a16="http://schemas.microsoft.com/office/drawing/2014/main" id="{33777796-DA57-446C-BE6E-304BCF619237}"/>
+                <a16:creationId xmlns:a16="http://schemas.microsoft.com/office/drawing/2014/main" id="{B8EB959C-A3BC-4D29-B2D9-415789A83F02}"/>
               </a:ext>
             </a:extLst>
           </p:cNvPr>
@@ -1331,7 +1331,7 @@
           <p:cNvPr id="2" name="">
             <a:extLst xmlns:a="http://schemas.openxmlformats.org/drawingml/2006/main">
               <a:ext uri="{FF2B5EF4-FFF2-40B4-BE49-F238E27FC236}">
-                <a16:creationId xmlns:a16="http://schemas.microsoft.com/office/drawing/2014/main" id="{B10994CC-BE0A-44D2-BFED-B7A347FE0624}"/>
+                <a16:creationId xmlns:a16="http://schemas.microsoft.com/office/drawing/2014/main" id="{8ABD6F7A-2401-4EA8-9F3C-DE00B95BB79D}"/>
               </a:ext>
             </a:extLst>
           </p:cNvPr>
@@ -1388,7 +1388,7 @@
           <p:cNvPr id="3" name="">
             <a:extLst xmlns:a="http://schemas.openxmlformats.org/drawingml/2006/main">
               <a:ext uri="{FF2B5EF4-FFF2-40B4-BE49-F238E27FC236}">
-                <a16:creationId xmlns:a16="http://schemas.microsoft.com/office/drawing/2014/main" id="{2BED0396-8A49-4A4F-B864-EE22ED998BCD}"/>
+                <a16:creationId xmlns:a16="http://schemas.microsoft.com/office/drawing/2014/main" id="{FF088A87-CF11-480B-A871-FEA8407BA51D}"/>
               </a:ext>
             </a:extLst>
           </p:cNvPr>
@@ -1445,7 +1445,7 @@
           <p:cNvPr id="4" name="">
             <a:extLst xmlns:a="http://schemas.openxmlformats.org/drawingml/2006/main">
               <a:ext uri="{FF2B5EF4-FFF2-40B4-BE49-F238E27FC236}">
-                <a16:creationId xmlns:a16="http://schemas.microsoft.com/office/drawing/2014/main" id="{813A6325-747B-40F5-BD98-C5A815DA5E93}"/>
+                <a16:creationId xmlns:a16="http://schemas.microsoft.com/office/drawing/2014/main" id="{DF01C4E6-9FFF-4C02-B329-9E470E7AEEAA}"/>
               </a:ext>
             </a:extLst>
           </p:cNvPr>
@@ -1492,7 +1492,7 @@
                 <a:ea typeface="Arial"/>
                 <a:cs typeface="Arial"/>
               </a:rPr>
-              <a:t>AI-ENG-110 / Topic 4 / 17 September 2026</a:t>
+              <a:t>AI-ENG-110 / Topic 4 / 18 September 2026</a:t>
             </a:r>
           </a:p>
         </p:txBody>
@@ -1500,7 +1500,7 @@
     </p:spTree>
     <p:extLst>
       <p:ext uri="{BB962C8B-B14F-4D97-AF65-F5344CB8AC3E}">
-        <p14:creationId xmlns:p14="http://schemas.microsoft.com/office/powerpoint/2010/main" val="1713923806"/>
+        <p14:creationId xmlns:p14="http://schemas.microsoft.com/office/powerpoint/2010/main" val="452417816"/>
       </p:ext>
     </p:extLst>
   </p:cSld>
@@ -1531,7 +1531,7 @@
           <p:cNvPr id="5" name="">
             <a:extLst xmlns:a="http://schemas.openxmlformats.org/drawingml/2006/main">
               <a:ext uri="{FF2B5EF4-FFF2-40B4-BE49-F238E27FC236}">
-                <a16:creationId xmlns:a16="http://schemas.microsoft.com/office/drawing/2014/main" id="{463B9C48-FA56-4D6B-A6CF-A293C14F854F}"/>
+                <a16:creationId xmlns:a16="http://schemas.microsoft.com/office/drawing/2014/main" id="{2F39B2F2-9DED-470E-A07C-0DFBF596036E}"/>
               </a:ext>
             </a:extLst>
           </p:cNvPr>
@@ -1588,7 +1588,7 @@
           <p:cNvPr id="2" name="">
             <a:extLst xmlns:a="http://schemas.openxmlformats.org/drawingml/2006/main">
               <a:ext uri="{FF2B5EF4-FFF2-40B4-BE49-F238E27FC236}">
-                <a16:creationId xmlns:a16="http://schemas.microsoft.com/office/drawing/2014/main" id="{EFD758D6-09F8-43CC-AA9B-D8212E867C3D}"/>
+                <a16:creationId xmlns:a16="http://schemas.microsoft.com/office/drawing/2014/main" id="{66C7FAAC-23DD-4123-A6FA-716AAC08F4F0}"/>
               </a:ext>
             </a:extLst>
           </p:cNvPr>
@@ -1645,7 +1645,7 @@
           <p:cNvPr id="3" name="">
             <a:extLst xmlns:a="http://schemas.openxmlformats.org/drawingml/2006/main">
               <a:ext uri="{FF2B5EF4-FFF2-40B4-BE49-F238E27FC236}">
-                <a16:creationId xmlns:a16="http://schemas.microsoft.com/office/drawing/2014/main" id="{45F111AF-CA9B-4D62-8F58-5976D1137993}"/>
+                <a16:creationId xmlns:a16="http://schemas.microsoft.com/office/drawing/2014/main" id="{2FD52DC6-7637-4206-8311-B7C5F1C4B8C9}"/>
               </a:ext>
             </a:extLst>
           </p:cNvPr>
@@ -1748,7 +1748,7 @@
           <p:cNvPr id="4" name="">
             <a:extLst xmlns:a="http://schemas.openxmlformats.org/drawingml/2006/main">
               <a:ext uri="{FF2B5EF4-FFF2-40B4-BE49-F238E27FC236}">
-                <a16:creationId xmlns:a16="http://schemas.microsoft.com/office/drawing/2014/main" id="{1ACAF95E-2D0B-4A83-8F1E-7976E5A99745}"/>
+                <a16:creationId xmlns:a16="http://schemas.microsoft.com/office/drawing/2014/main" id="{F28CE1B9-E540-4627-9974-D325A5A00724}"/>
               </a:ext>
             </a:extLst>
           </p:cNvPr>
@@ -1826,7 +1826,7 @@
     </p:spTree>
     <p:extLst>
       <p:ext uri="{BB962C8B-B14F-4D97-AF65-F5344CB8AC3E}">
-        <p14:creationId xmlns:p14="http://schemas.microsoft.com/office/powerpoint/2010/main" val="1188274546"/>
+        <p14:creationId xmlns:p14="http://schemas.microsoft.com/office/powerpoint/2010/main" val="338826351"/>
       </p:ext>
     </p:extLst>
   </p:cSld>
@@ -1857,7 +1857,7 @@
           <p:cNvPr id="6" name="">
             <a:extLst xmlns:a="http://schemas.openxmlformats.org/drawingml/2006/main">
               <a:ext uri="{FF2B5EF4-FFF2-40B4-BE49-F238E27FC236}">
-                <a16:creationId xmlns:a16="http://schemas.microsoft.com/office/drawing/2014/main" id="{03D9D98A-6662-43BF-B822-E2C42E5B9DC4}"/>
+                <a16:creationId xmlns:a16="http://schemas.microsoft.com/office/drawing/2014/main" id="{8265865D-14F5-4F92-9E7C-C60E922C0BAD}"/>
               </a:ext>
             </a:extLst>
           </p:cNvPr>
@@ -1914,7 +1914,7 @@
           <p:cNvPr id="2" name="">
             <a:extLst xmlns:a="http://schemas.openxmlformats.org/drawingml/2006/main">
               <a:ext uri="{FF2B5EF4-FFF2-40B4-BE49-F238E27FC236}">
-                <a16:creationId xmlns:a16="http://schemas.microsoft.com/office/drawing/2014/main" id="{5B517EDC-481F-4F31-A621-ECA0C45AAEA1}"/>
+                <a16:creationId xmlns:a16="http://schemas.microsoft.com/office/drawing/2014/main" id="{C194EA44-979A-4BF3-B997-BCB3F7B78B71}"/>
               </a:ext>
             </a:extLst>
           </p:cNvPr>
@@ -1971,7 +1971,7 @@
           <p:cNvPr id="3" name="">
             <a:extLst xmlns:a="http://schemas.openxmlformats.org/drawingml/2006/main">
               <a:ext uri="{FF2B5EF4-FFF2-40B4-BE49-F238E27FC236}">
-                <a16:creationId xmlns:a16="http://schemas.microsoft.com/office/drawing/2014/main" id="{F3FAC2DB-FF02-421C-B77D-6EA5C54FD09F}"/>
+                <a16:creationId xmlns:a16="http://schemas.microsoft.com/office/drawing/2014/main" id="{9E9F4BA2-5572-40A7-8318-4CC72FF1F98D}"/>
               </a:ext>
             </a:extLst>
           </p:cNvPr>
@@ -2074,7 +2074,7 @@
           <p:cNvPr id="4" name="">
             <a:extLst xmlns:a="http://schemas.openxmlformats.org/drawingml/2006/main">
               <a:ext uri="{FF2B5EF4-FFF2-40B4-BE49-F238E27FC236}">
-                <a16:creationId xmlns:a16="http://schemas.microsoft.com/office/drawing/2014/main" id="{CDA5BAB6-1356-434B-A641-028589C04B17}"/>
+                <a16:creationId xmlns:a16="http://schemas.microsoft.com/office/drawing/2014/main" id="{DAF1725E-6EBD-4443-BB65-9A7793ECDEDB}"/>
               </a:ext>
             </a:extLst>
           </p:cNvPr>
@@ -2121,7 +2121,7 @@
                 <a:ea typeface="Arial"/>
                 <a:cs typeface="Arial"/>
               </a:rPr>
-              <a:t>Verification still needed</a:t>
+              <a:t>Docker build and offline runs passed</a:t>
             </a:r>
           </a:p>
         </p:txBody>
@@ -2131,7 +2131,7 @@
           <p:cNvPr id="5" name="">
             <a:extLst xmlns:a="http://schemas.openxmlformats.org/drawingml/2006/main">
               <a:ext uri="{FF2B5EF4-FFF2-40B4-BE49-F238E27FC236}">
-                <a16:creationId xmlns:a16="http://schemas.microsoft.com/office/drawing/2014/main" id="{AB926F9F-14DF-4B26-8BD2-DFCD6CA36869}"/>
+                <a16:creationId xmlns:a16="http://schemas.microsoft.com/office/drawing/2014/main" id="{F01BB8EC-4EBE-4FE6-8A6B-FBDE902D04DE}"/>
               </a:ext>
             </a:extLst>
           </p:cNvPr>
@@ -2178,7 +2178,7 @@
                 <a:ea typeface="Arial"/>
                 <a:cs typeface="Arial"/>
               </a:rPr>
-              <a:t>Docker build/run and team fixes for existing lint/type errors</a:t>
+              <a:t>92 tests passed locally / lint and type checks passed in CI</a:t>
             </a:r>
           </a:p>
         </p:txBody>
@@ -2186,7 +2186,7 @@
     </p:spTree>
     <p:extLst>
       <p:ext uri="{BB962C8B-B14F-4D97-AF65-F5344CB8AC3E}">
-        <p14:creationId xmlns:p14="http://schemas.microsoft.com/office/powerpoint/2010/main" val="2017083824"/>
+        <p14:creationId xmlns:p14="http://schemas.microsoft.com/office/powerpoint/2010/main" val="983857512"/>
       </p:ext>
     </p:extLst>
   </p:cSld>
@@ -2217,7 +2217,7 @@
           <p:cNvPr id="4" name="">
             <a:extLst xmlns:a="http://schemas.openxmlformats.org/drawingml/2006/main">
               <a:ext uri="{FF2B5EF4-FFF2-40B4-BE49-F238E27FC236}">
-                <a16:creationId xmlns:a16="http://schemas.microsoft.com/office/drawing/2014/main" id="{8C08314F-2911-40C4-A3C7-51B31BEEEE60}"/>
+                <a16:creationId xmlns:a16="http://schemas.microsoft.com/office/drawing/2014/main" id="{625499E1-6394-476A-BC06-C37C71696FBC}"/>
               </a:ext>
             </a:extLst>
           </p:cNvPr>
@@ -2274,7 +2274,7 @@
           <p:cNvPr id="2" name="">
             <a:extLst xmlns:a="http://schemas.openxmlformats.org/drawingml/2006/main">
               <a:ext uri="{FF2B5EF4-FFF2-40B4-BE49-F238E27FC236}">
-                <a16:creationId xmlns:a16="http://schemas.microsoft.com/office/drawing/2014/main" id="{4A90EF4C-B52F-44CF-8A9F-EEAA4A32A7F5}"/>
+                <a16:creationId xmlns:a16="http://schemas.microsoft.com/office/drawing/2014/main" id="{C64A1214-2734-4F7B-A79A-B453A718A4D0}"/>
               </a:ext>
             </a:extLst>
           </p:cNvPr>
@@ -2377,7 +2377,7 @@
           <p:cNvPr id="3" name="">
             <a:extLst xmlns:a="http://schemas.openxmlformats.org/drawingml/2006/main">
               <a:ext uri="{FF2B5EF4-FFF2-40B4-BE49-F238E27FC236}">
-                <a16:creationId xmlns:a16="http://schemas.microsoft.com/office/drawing/2014/main" id="{0D0CB4D5-2E92-49CD-BE21-0451961C3877}"/>
+                <a16:creationId xmlns:a16="http://schemas.microsoft.com/office/drawing/2014/main" id="{632DED05-3B81-4428-8A64-A82947A9B353}"/>
               </a:ext>
             </a:extLst>
           </p:cNvPr>
@@ -2432,7 +2432,7 @@
     </p:spTree>
     <p:extLst>
       <p:ext uri="{BB962C8B-B14F-4D97-AF65-F5344CB8AC3E}">
-        <p14:creationId xmlns:p14="http://schemas.microsoft.com/office/powerpoint/2010/main" val="821636891"/>
+        <p14:creationId xmlns:p14="http://schemas.microsoft.com/office/powerpoint/2010/main" val="705703176"/>
       </p:ext>
     </p:extLst>
   </p:cSld>

</xml_diff>